<commit_message>
Apply Jalour answers: funding-gap source, separate-account position, delivery-price comparison, NDA-gated sponsor material; rebuild all packs
Co-Authored-By: Claude Sonnet 5.5 <noreply@anthropic.com>
Claude-Session: https://claude.ai/code/session_01Tace5U23AKexiDyfCZxMPM
</commit_message>
<xml_diff>
--- a/output/GS_050M/Deck.pptx
+++ b/output/GS_050M/Deck.pptx
@@ -6697,7 +6697,7 @@
                   <a:srgbClr val="1B1F2A"/>
                 </a:solidFill>
               </a:rPr>
-              <a:t>If delivery payments arrive at handover the peak shortage is EGP 269 million; if sales slip 12 months with prices 10% lower it is EGP 441 million. Jalour will fund gaps above project cash.</a:t>
+              <a:t>If delivery payments arrive at handover the peak shortage is EGP 269 million; if sales slip 12 months with prices 10% lower it is EGP 441 million. Jalour will cover gaps above project cash from its cash reserves and cash from other projects it is constructing.</a:t>
             </a:r>
             <a:endParaRPr lang="en-US" sz="1300" dirty="0"/>
           </a:p>
@@ -7518,7 +7518,7 @@
                             <a:srgbClr val="1B1F2A"/>
                           </a:solidFill>
                         </a:rPr>
-                        <a:t>Yes: value moves with Mostakbal City prices (final list 1.43x launch)</a:t>
+                        <a:t>Yes: value moves with Mostakbal City prices (delivery list 1.43x launch)</a:t>
                       </a:r>
                       <a:endParaRPr lang="en-US" sz="1300" dirty="0"/>
                     </a:p>
@@ -9073,7 +9073,7 @@
                   <a:srgbClr val="1B1F2A"/>
                 </a:solidFill>
               </a:rPr>
-              <a:t>Sponsor funding undertaking for project funding gaps; no guarantee of return</a:t>
+              <a:t>Sponsor funding undertaking for project gaps from Jalour cash reserves and other projects' cash; no guarantee of return</a:t>
             </a:r>
             <a:endParaRPr lang="en-US" sz="1300" dirty="0"/>
           </a:p>
@@ -10960,7 +10960,7 @@
                   <a:srgbClr val="1B1F2A"/>
                 </a:solidFill>
               </a:rPr>
-              <a:t>Option A break-even: the units could be resold at 36% of the final list price before the ticket is lost.</a:t>
+              <a:t>Option A break-even: the units could be resold at 36% of the delivery list price before the ticket is lost.</a:t>
             </a:r>
             <a:endParaRPr lang="en-US" sz="1200" dirty="0"/>
           </a:p>
@@ -11499,7 +11499,7 @@
                             <a:srgbClr val="1B1F2A"/>
                           </a:solidFill>
                         </a:rPr>
-                        <a:t>Contractual milestone; Jalour funds any gap; stress case shown</a:t>
+                        <a:t>Contractual milestone; Jalour covers any gap from cash reserves and other projects' cash; stress case shown</a:t>
                       </a:r>
                       <a:endParaRPr lang="en-US" sz="1200" dirty="0"/>
                     </a:p>
@@ -16867,7 +16867,7 @@
                             <a:srgbClr val="1B1F2A"/>
                           </a:solidFill>
                         </a:rPr>
-                        <a:t>Launch EGP 135,000 per m2, rising to 200,000 at the final list</a:t>
+                        <a:t>Launch EGP 135,000 per m2, rising to 200,000 at the delivery list</a:t>
                       </a:r>
                       <a:endParaRPr lang="en-US" sz="1200" dirty="0"/>
                     </a:p>
@@ -17237,7 +17237,7 @@
                             <a:srgbClr val="1B1F2A"/>
                           </a:solidFill>
                         </a:rPr>
-                        <a:t>Launch to final list: +33% retail, +48% offices over the sales window</a:t>
+                        <a:t>Launch to delivery list: +33% retail, +48% offices; offices +77% on today's asking, about 15% a year</a:t>
                       </a:r>
                       <a:endParaRPr lang="en-US" sz="1200" dirty="0"/>
                     </a:p>
@@ -20176,7 +20176,7 @@
                   <a:srgbClr val="1B1F2A"/>
                 </a:solidFill>
               </a:rPr>
-              <a:t>Funds project funding gaps from sponsor equity or other capital sources (to be documented)</a:t>
+              <a:t>Covers project funding gaps from its cash reserves and cash from other projects it is constructing (to be documented)</a:t>
             </a:r>
             <a:endParaRPr lang="en-US" sz="1400" dirty="0"/>
           </a:p>
@@ -20277,7 +20277,7 @@
                   <a:srgbClr val="1B1F2A"/>
                 </a:solidFill>
               </a:rPr>
-              <a:t>[To be provided by Jalour: completed projects, area delivered and units handed over]</a:t>
+              <a:t>Completed projects, area delivered and units handed over</a:t>
             </a:r>
             <a:endParaRPr lang="en-US" sz="1400" dirty="0"/>
           </a:p>
@@ -20295,7 +20295,7 @@
                   <a:srgbClr val="1B1F2A"/>
                 </a:solidFill>
               </a:rPr>
-              <a:t>[To be provided by Jalour: management team biographies]</a:t>
+              <a:t>Management team biographies</a:t>
             </a:r>
             <a:endParaRPr lang="en-US" sz="1400" dirty="0"/>
           </a:p>
@@ -20313,7 +20313,7 @@
                   <a:srgbClr val="1B1F2A"/>
                 </a:solidFill>
               </a:rPr>
-              <a:t>[To be provided by Jalour: audited financial statements of Jalour and Al Jalal Holding]</a:t>
+              <a:t>Audited financial statements of Jalour and Al Jalal Holding</a:t>
             </a:r>
             <a:endParaRPr lang="en-US" sz="1400" dirty="0"/>
           </a:p>
@@ -20331,7 +20331,25 @@
                   <a:srgbClr val="1B1F2A"/>
                 </a:solidFill>
               </a:rPr>
-              <a:t>[To be provided by Jalour: references from landlords, contractors and buyers]</a:t>
+              <a:t>References from landlords, contractors and buyers</a:t>
+            </a:r>
+            <a:endParaRPr lang="en-US" sz="1400" dirty="0"/>
+          </a:p>
+          <a:p>
+            <a:pPr marL="342900" indent="-342900">
+              <a:spcAft>
+                <a:spcPts val="600"/>
+              </a:spcAft>
+              <a:buSzPct val="100000"/>
+              <a:buChar char="•"/>
+            </a:pPr>
+            <a:r>
+              <a:rPr lang="en-US" sz="1400" dirty="0">
+                <a:solidFill>
+                  <a:srgbClr val="1B1F2A"/>
+                </a:solidFill>
+              </a:rPr>
+              <a:t>All provided after the investor signs a non-disclosure agreement</a:t>
             </a:r>
             <a:endParaRPr lang="en-US" sz="1400" dirty="0"/>
           </a:p>
@@ -20367,7 +20385,7 @@
                   <a:srgbClr val="6B7280"/>
                 </a:solidFill>
               </a:rPr>
-              <a:t>Source: Jalour Developments is the real estate arm of Al Jalal Holding, Cairo. Placeholders in brackets are pending from Jalour.</a:t>
+              <a:t>Source: Jalour Developments is the real estate arm of Al Jalal Holding, Cairo. Sponsor materials are provided after the investor signs a non-disclosure agreement.</a:t>
             </a:r>
             <a:endParaRPr lang="en-US" sz="900" dirty="0"/>
           </a:p>
@@ -20665,7 +20683,7 @@
                             <a:srgbClr val="FFFFFF"/>
                           </a:solidFill>
                         </a:rPr>
-                        <a:t>Final</a:t>
+                        <a:t>Delivery list</a:t>
                       </a:r>
                       <a:endParaRPr lang="en-US" sz="1200" dirty="0"/>
                     </a:p>

</xml_diff>

<commit_message>
Combined 125M investor pack (62.5M in each project), NDA template in every pack, confidentiality banners, QA
Co-Authored-By: Claude Sonnet 5.5 <noreply@anthropic.com>
Claude-Session: https://claude.ai/code/session_01Tace5U23AKexiDyfCZxMPM
</commit_message>
<xml_diff>
--- a/output/GS_050M/Deck.pptx
+++ b/output/GS_050M/Deck.pptx
@@ -4643,6 +4643,42 @@
         </p:nvSpPr>
         <p:spPr>
           <a:xfrm>
+            <a:off x="731520" y="5074920"/>
+            <a:ext cx="10515600" cy="548640"/>
+          </a:xfrm>
+          <a:prstGeom prst="rect">
+            <a:avLst/>
+          </a:prstGeom>
+          <a:noFill/>
+          <a:ln/>
+        </p:spPr>
+        <p:txBody>
+          <a:bodyPr wrap="square" lIns="0" tIns="0" rIns="0" bIns="0" rtlCol="0" anchor="ctr"/>
+          <a:lstStyle/>
+          <a:p>
+            <a:pPr indent="0" marL="0">
+              <a:buNone/>
+            </a:pPr>
+            <a:r>
+              <a:rPr lang="en-US" sz="1300" b="1" dirty="0">
+                <a:solidFill>
+                  <a:srgbClr val="B8893B"/>
+                </a:solidFill>
+              </a:rPr>
+              <a:t>ALL INFORMATION IN THIS PRESENTATION IS CONFIDENTIAL AND SUBJECT TO THE NON-DISCLOSURE AGREEMENT. Do not copy, forward or disclose it.</a:t>
+            </a:r>
+            <a:endParaRPr lang="en-US" sz="1300" dirty="0"/>
+          </a:p>
+        </p:txBody>
+      </p:sp>
+      <p:sp>
+        <p:nvSpPr>
+          <p:cNvPr id="7" name="Text 5"/>
+          <p:cNvSpPr txBox="1"/>
+          <p:nvPr/>
+        </p:nvSpPr>
+        <p:spPr>
+          <a:xfrm>
             <a:off x="731520" y="5852160"/>
             <a:ext cx="10515600" cy="365760"/>
           </a:xfrm>
@@ -13837,7 +13873,7 @@
                   <a:srgbClr val="AAB2BD"/>
                 </a:solidFill>
               </a:rPr>
-              <a:t>Jalour may raise further capital at project or holding level, subject to the investor's stated rights. Projections are not guarantees. Strictly private and confidential.</a:t>
+              <a:t>Jalour may raise further capital at project or holding level, subject to the investor's stated rights. Projections are not guarantees. All information in this presentation and in the other documents of this pack is confidential and subject to the non-disclosure agreement.</a:t>
             </a:r>
             <a:endParaRPr lang="en-US" sz="1100" dirty="0"/>
           </a:p>

</xml_diff>